<commit_message>
Settlement visibility + ops STP-exception retry; presentation pack reworked for 4 presenters / 10+5
</commit_message>
<xml_diff>
--- a/presentation/STP-final-presentation.pptx
+++ b/presentation/STP-final-presentation.pptx
@@ -543,12 +543,12 @@
           <a:p/>
           <a:p>
             <a:r>
-              <a:t>(Replace [Team name] / [Member …] placeholders; presenters P1–P5 per script §1:</a:t>
-            </a:r>
-          </a:p>
-          <a:p>
-            <a:r>
-              <a:t>P1 corporate lead, P2/P4 technology, P3/P5 corporate.)</a:t>
+              <a:t>(Replace [Team name] / [Member …] placeholders; presenters P1–P4 per script §1:</a:t>
+            </a:r>
+          </a:p>
+          <a:p>
+            <a:r>
+              <a:t>P1 corporate lead, P2/P4 technology, P3 corporate.)</a:t>
             </a:r>
           </a:p>
         </p:txBody>
@@ -733,7 +733,7 @@
           <a:lstStyle/>
           <a:p>
             <a:r>
-              <a:t>Design before code: twenty-four numbered design documents, one per module or</a:t>
+              <a:t>Design before code: twenty-six numbered design documents, one per module or</a:t>
             </a:r>
           </a:p>
           <a:p>
@@ -743,57 +743,52 @@
           </a:p>
           <a:p>
             <a:r>
-              <a:t>off an integration branch — you can see nine merges and seven feature branches</a:t>
-            </a:r>
-          </a:p>
-          <a:p>
-            <a:r>
-              <a:t>in the history — with a dated changelog entry per milestone. Every milestone</a:t>
-            </a:r>
-          </a:p>
-          <a:p>
-            <a:r>
-              <a:t>was verified the same way: the full test suite, the strict TypeScript build,</a:t>
-            </a:r>
-          </a:p>
-          <a:p>
-            <a:r>
-              <a:t>an end-to-end walk of the real stack, and headless-browser screenshots for UI</a:t>
-            </a:r>
-          </a:p>
-          <a:p>
-            <a:r>
-              <a:t>changes — verified by a second pair of eyes, never trusted on the author's</a:t>
-            </a:r>
-          </a:p>
-          <a:p>
-            <a:r>
-              <a:t>word. CI/CD is defined as a six-stage GitLab pipeline — lint, test, security</a:t>
-            </a:r>
-          </a:p>
-          <a:p>
-            <a:r>
-              <a:t>scan, build, deploy-dev, deploy-demo — with Docker images for both tiers and</a:t>
-            </a:r>
-          </a:p>
-          <a:p>
-            <a:r>
-              <a:t>Terraform for a single-VM cloud deployment. Honest caveat: the pipeline,</a:t>
-            </a:r>
-          </a:p>
-          <a:p>
-            <a:r>
-              <a:t>containers and Terraform are written and statically reviewed, but no cloud was</a:t>
-            </a:r>
-          </a:p>
-          <a:p>
-            <a:r>
-              <a:t>available in the program environment — they have not been executed. That stays</a:t>
-            </a:r>
-          </a:p>
-          <a:p>
-            <a:r>
-              <a:t>on the roadmap slide.</a:t>
+              <a:t>off an integration branch — you can see thirteen merges and twelve feature</a:t>
+            </a:r>
+          </a:p>
+          <a:p>
+            <a:r>
+              <a:t>branches in the history — with a dated changelog entry per milestone. Every</a:t>
+            </a:r>
+          </a:p>
+          <a:p>
+            <a:r>
+              <a:t>milestone was verified the same way: the full test suite, the strict TypeScript</a:t>
+            </a:r>
+          </a:p>
+          <a:p>
+            <a:r>
+              <a:t>build, an end-to-end walk of the real stack, and headless-browser screenshots</a:t>
+            </a:r>
+          </a:p>
+          <a:p>
+            <a:r>
+              <a:t>for UI changes — checked by a second pair of eyes, never trusted on the</a:t>
+            </a:r>
+          </a:p>
+          <a:p>
+            <a:r>
+              <a:t>author's word. CI/CD is a defined six-stage GitLab pipeline — lint, test,</a:t>
+            </a:r>
+          </a:p>
+          <a:p>
+            <a:r>
+              <a:t>security scan, build, deploy-dev, deploy-demo — with Docker images and</a:t>
+            </a:r>
+          </a:p>
+          <a:p>
+            <a:r>
+              <a:t>Terraform for a single-VM cloud deployment. Honest caveat: written and</a:t>
+            </a:r>
+          </a:p>
+          <a:p>
+            <a:r>
+              <a:t>statically reviewed, but not executed — no cloud in the program environment.</a:t>
+            </a:r>
+          </a:p>
+          <a:p>
+            <a:r>
+              <a:t>That stays on the roadmap.</a:t>
             </a:r>
           </a:p>
         </p:txBody>
@@ -919,7 +914,7 @@
           </a:p>
           <a:p>
             <a:r>
-              <a:t>[P5]."</a:t>
+              <a:t>[P1]."</a:t>
             </a:r>
           </a:p>
         </p:txBody>
@@ -989,7 +984,17 @@
           <a:lstStyle/>
           <a:p>
             <a:r>
-              <a:t>Three war stories, all real.</a:t>
+              <a:t>One story live — the dataset one, in forty seconds. The other two stay on the</a:t>
+            </a:r>
+          </a:p>
+          <a:p>
+            <a:r>
+              <a:t>slide and in these notes as Q&amp;A ammunition (script §9) for any "what was hard /</a:t>
+            </a:r>
+          </a:p>
+          <a:p>
+            <a:r>
+              <a:t>what went wrong?" question.</a:t>
             </a:r>
           </a:p>
           <a:p/>
@@ -1132,7 +1137,7 @@
           <a:lstStyle/>
           <a:p>
             <a:r>
-              <a:t>Worked: design-first — 24 design docs meant feedback rounds changed documents</a:t>
+              <a:t>Worked: design-first — 26 design docs meant feedback rounds changed documents</a:t>
             </a:r>
           </a:p>
           <a:p>
@@ -1142,7 +1147,7 @@
           </a:p>
           <a:p>
             <a:r>
-              <a:t>manual hack. Verification discipline — 87 tests, a strict build, and</a:t>
+              <a:t>manual hack. Verification discipline — ~100 tests, a strict build, and</a:t>
             </a:r>
           </a:p>
           <a:p>
@@ -1179,7 +1184,12 @@
           <a:p/>
           <a:p>
             <a:r>
-              <a:t>Handover: "So what did three weeks teach us — [P1]."</a:t>
+              <a:t>Handover: "So what did three weeks teach us, and where does it go next —</a:t>
+            </a:r>
+          </a:p>
+          <a:p>
+            <a:r>
+              <a:t>[P3]."</a:t>
             </a:r>
           </a:p>
         </p:txBody>
@@ -1249,6 +1259,17 @@
           <a:lstStyle/>
           <a:p>
             <a:r>
+              <a:t>(Compressed for the 10-minute slot: one line per category — the full text</a:t>
+            </a:r>
+          </a:p>
+          <a:p>
+            <a:r>
+              <a:t>below is reference.)</a:t>
+            </a:r>
+          </a:p>
+          <a:p/>
+          <a:p>
+            <a:r>
               <a:t>Technical: event-driven design pays for itself the first time a requirement</a:t>
             </a:r>
           </a:p>
@@ -1312,7 +1333,12 @@
           <a:p/>
           <a:p>
             <a:r>
-              <a:t>Handover: "Which brings us back to the four people we started with — [P3]."</a:t>
+              <a:t>Transition (same speaker continues): "Which brings us back to the four people</a:t>
+            </a:r>
+          </a:p>
+          <a:p>
+            <a:r>
+              <a:t>we started with."</a:t>
             </a:r>
           </a:p>
         </p:txBody>
@@ -1382,12 +1408,12 @@
           <a:lstStyle/>
           <a:p>
             <a:r>
-              <a:t>28 commits on the integration branch, 9 merges, 7 feature branches. 87</a:t>
-            </a:r>
-          </a:p>
-          <a:p>
-            <a:r>
-              <a:t>backend tests, all green. 16 backend modules, 24 design documents, a dated</a:t>
+              <a:t>42 commits on the integration branch, 14 merges, 12 feature branches. ~100</a:t>
+            </a:r>
+          </a:p>
+          <a:p>
+            <a:r>
+              <a:t>backend tests, all green. 17 backend modules, 26 design documents, a dated</a:t>
             </a:r>
           </a:p>
           <a:p>
@@ -1509,7 +1535,7 @@
           </a:p>
           <a:p>
             <a:r>
-              <a:t>touching the guardrails; the batch system's knowledge is preserved in 24</a:t>
+              <a:t>touching the guardrails; the batch system's knowledge is preserved in 26</a:t>
             </a:r>
           </a:p>
           <a:p>
@@ -1818,23 +1844,28 @@
           <a:lstStyle/>
           <a:p>
             <a:r>
-              <a:t>Quick roadmap of the next fifteen minutes: what we built, how it supports real</a:t>
-            </a:r>
-          </a:p>
-          <a:p>
-            <a:r>
-              <a:t>operational workflows, how we worked as a cross-functional team, what worked</a:t>
-            </a:r>
-          </a:p>
-          <a:p>
-            <a:r>
-              <a:t>and what didn't, and where this goes next.</a:t>
+              <a:t>Quick roadmap of the next ten minutes: what we built — including a live</a:t>
+            </a:r>
+          </a:p>
+          <a:p>
+            <a:r>
+              <a:t>90-second demo — how it supports real operational workflows, how we worked as</a:t>
+            </a:r>
+          </a:p>
+          <a:p>
+            <a:r>
+              <a:t>a cross-functional team, what held up and what didn't, and where this goes</a:t>
+            </a:r>
+          </a:p>
+          <a:p>
+            <a:r>
+              <a:t>next.</a:t>
             </a:r>
           </a:p>
           <a:p/>
           <a:p>
             <a:r>
-              <a:t>Timing per script §1: demo section gets the biggest block (45%). Appendix</a:t>
+              <a:t>Timing per script §1: the demo section gets the biggest block (35%). Appendix</a:t>
             </a:r>
           </a:p>
           <a:p>
@@ -2664,7 +2695,17 @@
           </a:p>
           <a:p>
             <a:r>
-              <a:t>*settled* — that is straight-through processing.</a:t>
+              <a:t>*settled* — that is straight-through processing. The settlement lifecycle is</a:t>
+            </a:r>
+          </a:p>
+          <a:p>
+            <a:r>
+              <a:t>visible in the UI: the settlements list shows every state, and ops can retry</a:t>
+            </a:r>
+          </a:p>
+          <a:p>
+            <a:r>
+              <a:t>exceptions.</a:t>
             </a:r>
           </a:p>
           <a:p/>
@@ -2680,7 +2721,7 @@
           </a:p>
           <a:p>
             <a:r>
-              <a:t>status FILLED → settlement instruction → SETTLED.</a:t>
+              <a:t>status FILLED → settlement instruction → SETTLED in the settlements list.</a:t>
             </a:r>
           </a:p>
           <a:p/>
@@ -2777,27 +2818,27 @@
           </a:p>
           <a:p>
             <a:r>
-              <a:t>EXECUTED → AFFIRMED → SETTLED automatically. Exceptions surface on the</a:t>
-            </a:r>
-          </a:p>
-          <a:p>
-            <a:r>
-              <a:t>operations dashboard for the Operations Analyst, with audit on every</a:t>
-            </a:r>
-          </a:p>
-          <a:p>
-            <a:r>
-              <a:t>transition. The same pipeline serves client books, house books and paper</a:t>
-            </a:r>
-          </a:p>
-          <a:p>
-            <a:r>
-              <a:t>accounts — paper trading isn't a toy mode, it's the same code path with a</a:t>
-            </a:r>
-          </a:p>
-          <a:p>
-            <a:r>
-              <a:t>portfolio type flag.</a:t>
+              <a:t>EXECUTED → AFFIRMED → SETTLED automatically — every state visible in the</a:t>
+            </a:r>
+          </a:p>
+          <a:p>
+            <a:r>
+              <a:t>settlements list. Exceptions surface on the operations dashboard, with audit on</a:t>
+            </a:r>
+          </a:p>
+          <a:p>
+            <a:r>
+              <a:t>every transition, and ops can retry an exception from the same dashboard. The</a:t>
+            </a:r>
+          </a:p>
+          <a:p>
+            <a:r>
+              <a:t>same pipeline serves client, house and paper books — paper trading isn't a toy</a:t>
+            </a:r>
+          </a:p>
+          <a:p>
+            <a:r>
+              <a:t>mode, it's the same code path with a portfolio type flag.</a:t>
             </a:r>
           </a:p>
           <a:p/>
@@ -6146,7 +6187,7 @@
                 </a:solidFill>
                 <a:latin typeface="Segoe UI"/>
               </a:rPr>
-              <a:t>[Team name]  —  [Member 1] · [Member 2] · [Member 3] · [Member 4] · [Member 5]</a:t>
+              <a:t>[Team name]  —  [Member 1] · [Member 2] · [Member 3] · [Member 4]</a:t>
             </a:r>
           </a:p>
         </p:txBody>
@@ -7371,7 +7412,7 @@
                 </a:solidFill>
                 <a:latin typeface="Segoe UI"/>
               </a:rPr>
-              <a:t>24 numbered design documents, one per module or major feature, each traced to SRS requirement IDs.</a:t>
+              <a:t>26 numbered design documents, one per module or major feature, each traced to SRS requirement IDs.</a:t>
             </a:r>
           </a:p>
           <a:p>
@@ -7408,7 +7449,7 @@
                 </a:solidFill>
                 <a:latin typeface="Segoe UI"/>
               </a:rPr>
-              <a:t>feature branches off an integration branch — 9 merges, 7 feature branches in the history — plus a dated changelog entry per milestone.</a:t>
+              <a:t>feature branches off an integration branch — 13 merges, 12 feature branches in the history — plus a dated changelog entry per milestone.</a:t>
             </a:r>
           </a:p>
           <a:p>
@@ -10490,7 +10531,7 @@
                 </a:solidFill>
                 <a:latin typeface="Segoe UI"/>
               </a:rPr>
-              <a:t>24 design docs meant feedback rounds changed documents before they changed code.</a:t>
+              <a:t>26 design docs meant feedback rounds changed documents before they changed code.</a:t>
             </a:r>
           </a:p>
           <a:p>
@@ -10564,7 +10605,7 @@
                 </a:solidFill>
                 <a:latin typeface="Segoe UI"/>
               </a:rPr>
-              <a:t>87 tests, a strict build, and screenshot-verified UI rounds.</a:t>
+              <a:t>~100 tests, a strict build, and screenshot-verified UI rounds.</a:t>
             </a:r>
           </a:p>
         </p:txBody>
@@ -11581,7 +11622,7 @@
                 </a:solidFill>
                 <a:latin typeface="Segoe UI"/>
               </a:rPr>
-              <a:t>SECTION 7 · ROADMAP &amp; CLOSE</a:t>
+              <a:t>SECTION 6 · ROADMAP &amp; CLOSE</a:t>
             </a:r>
           </a:p>
         </p:txBody>
@@ -11773,7 +11814,7 @@
                 </a:solidFill>
                 <a:latin typeface="Segoe UI"/>
               </a:rPr>
-              <a:t>28</a:t>
+              <a:t>42</a:t>
             </a:r>
           </a:p>
           <a:p>
@@ -11856,7 +11897,7 @@
                 </a:solidFill>
                 <a:latin typeface="Segoe UI"/>
               </a:rPr>
-              <a:t>9</a:t>
+              <a:t>14</a:t>
             </a:r>
           </a:p>
           <a:p>
@@ -11939,7 +11980,7 @@
                 </a:solidFill>
                 <a:latin typeface="Segoe UI"/>
               </a:rPr>
-              <a:t>7</a:t>
+              <a:t>12</a:t>
             </a:r>
           </a:p>
           <a:p>
@@ -12022,7 +12063,7 @@
                 </a:solidFill>
                 <a:latin typeface="Segoe UI"/>
               </a:rPr>
-              <a:t>87</a:t>
+              <a:t>~100</a:t>
             </a:r>
           </a:p>
           <a:p>
@@ -12105,7 +12146,7 @@
                 </a:solidFill>
                 <a:latin typeface="Segoe UI"/>
               </a:rPr>
-              <a:t>16</a:t>
+              <a:t>17</a:t>
             </a:r>
           </a:p>
           <a:p>
@@ -12188,7 +12229,7 @@
                 </a:solidFill>
                 <a:latin typeface="Segoe UI"/>
               </a:rPr>
-              <a:t>24</a:t>
+              <a:t>26</a:t>
             </a:r>
           </a:p>
           <a:p>
@@ -12714,7 +12755,7 @@
                 </a:solidFill>
                 <a:latin typeface="Segoe UI"/>
               </a:rPr>
-              <a:t>SECTION 7 · ROADMAP &amp; CLOSE</a:t>
+              <a:t>SECTION 6 · ROADMAP &amp; CLOSE</a:t>
             </a:r>
           </a:p>
         </p:txBody>
@@ -13354,7 +13395,7 @@
                 </a:solidFill>
                 <a:latin typeface="Segoe UI"/>
               </a:rPr>
-              <a:t>Batch-system knowledge preserved in 24 design docs and a runbook</a:t>
+              <a:t>Batch-system knowledge preserved in 26 design docs and a runbook</a:t>
             </a:r>
           </a:p>
           <a:p>
@@ -15422,7 +15463,7 @@
                 </a:solidFill>
                 <a:latin typeface="Segoe UI"/>
               </a:rPr>
-              <a:t>15 MINUTES + 5 MINUTES Q&amp;A</a:t>
+              <a:t>10 MINUTES + 5 MINUTES Q&amp;A</a:t>
             </a:r>
           </a:p>
         </p:txBody>
@@ -15696,7 +15737,7 @@
                 </a:solidFill>
                 <a:latin typeface="Segoe UI"/>
               </a:rPr>
-              <a:t>P1 · 0:00–1:00</a:t>
+              <a:t>P1 · 0:00–0:45</a:t>
             </a:r>
           </a:p>
         </p:txBody>
@@ -15842,7 +15883,7 @@
                 </a:solidFill>
                 <a:latin typeface="Segoe UI"/>
               </a:rPr>
-              <a:t>P2 · 1:00–5:00</a:t>
+              <a:t>P2 · 0:45–4:15</a:t>
             </a:r>
           </a:p>
         </p:txBody>
@@ -15988,7 +16029,7 @@
                 </a:solidFill>
                 <a:latin typeface="Segoe UI"/>
               </a:rPr>
-              <a:t>P3 · 5:00–7:00</a:t>
+              <a:t>P3 · 4:15–5:45</a:t>
             </a:r>
           </a:p>
         </p:txBody>
@@ -16134,7 +16175,7 @@
                 </a:solidFill>
                 <a:latin typeface="Segoe UI"/>
               </a:rPr>
-              <a:t>P4 · 7:00–10:30</a:t>
+              <a:t>P4 · 5:45–7:45</a:t>
             </a:r>
           </a:p>
         </p:txBody>
@@ -16280,7 +16321,7 @@
                 </a:solidFill>
                 <a:latin typeface="Segoe UI"/>
               </a:rPr>
-              <a:t>P5 · 10:30–12:30</a:t>
+              <a:t>P1 · 7:45–9:00</a:t>
             </a:r>
           </a:p>
         </p:txBody>
@@ -16384,7 +16425,7 @@
                 </a:solidFill>
                 <a:latin typeface="Segoe UI"/>
               </a:rPr>
-              <a:t>What we learned</a:t>
+              <a:t>Learnings, roadmap &amp; close</a:t>
             </a:r>
           </a:p>
         </p:txBody>
@@ -16426,7 +16467,7 @@
                 </a:solidFill>
                 <a:latin typeface="Segoe UI"/>
               </a:rPr>
-              <a:t>P1 · 12:30–14:00</a:t>
+              <a:t>P3 · 9:00–10:00</a:t>
             </a:r>
           </a:p>
         </p:txBody>
@@ -16530,7 +16571,7 @@
                 </a:solidFill>
                 <a:latin typeface="Segoe UI"/>
               </a:rPr>
-              <a:t>Roadmap &amp; close</a:t>
+              <a:t>Q&amp;A</a:t>
             </a:r>
           </a:p>
         </p:txBody>
@@ -16572,153 +16613,7 @@
                 </a:solidFill>
                 <a:latin typeface="Segoe UI"/>
               </a:rPr>
-              <a:t>P3 · 14:00–15:00</a:t>
-            </a:r>
-          </a:p>
-        </p:txBody>
-      </p:sp>
-      <p:sp>
-        <p:nvSpPr>
-          <p:cNvPr id="28" name="Rounded Rectangle 27"/>
-          <p:cNvSpPr/>
-          <p:nvPr/>
-        </p:nvSpPr>
-        <p:spPr>
-          <a:xfrm>
-            <a:off x="548640" y="5385816"/>
-            <a:ext cx="384048" cy="384048"/>
-          </a:xfrm>
-          <a:prstGeom prst="roundRect">
-            <a:avLst>
-              <a:gd name="adj" fmla="val 25000"/>
-            </a:avLst>
-          </a:prstGeom>
-          <a:solidFill>
-            <a:srgbClr val="1F3864"/>
-          </a:solidFill>
-          <a:ln>
-            <a:noFill/>
-          </a:ln>
-          <a:effectLst/>
-        </p:spPr>
-        <p:style>
-          <a:lnRef idx="1">
-            <a:schemeClr val="accent1"/>
-          </a:lnRef>
-          <a:fillRef idx="3">
-            <a:schemeClr val="accent1"/>
-          </a:fillRef>
-          <a:effectRef idx="2">
-            <a:schemeClr val="accent1"/>
-          </a:effectRef>
-          <a:fontRef idx="minor">
-            <a:schemeClr val="lt1"/>
-          </a:fontRef>
-        </p:style>
-        <p:txBody>
-          <a:bodyPr rtlCol="0" anchor="ctr" wrap="square" lIns="18288" rIns="18288" tIns="18288" bIns="18288"/>
-          <a:lstStyle/>
-          <a:p>
-            <a:pPr algn="ctr">
-              <a:lnSpc>
-                <a:spcPct val="100000"/>
-              </a:lnSpc>
-              <a:spcAft>
-                <a:spcPts val="200"/>
-              </a:spcAft>
-            </a:pPr>
-            <a:r>
-              <a:rPr sz="1400" b="1" i="0">
-                <a:solidFill>
-                  <a:srgbClr val="FFFFFF"/>
-                </a:solidFill>
-                <a:latin typeface="Segoe UI"/>
-              </a:rPr>
-              <a:t>8</a:t>
-            </a:r>
-          </a:p>
-        </p:txBody>
-      </p:sp>
-      <p:sp>
-        <p:nvSpPr>
-          <p:cNvPr id="29" name="TextBox 28"/>
-          <p:cNvSpPr txBox="1"/>
-          <p:nvPr/>
-        </p:nvSpPr>
-        <p:spPr>
-          <a:xfrm>
-            <a:off x="1188720" y="5413248"/>
-            <a:ext cx="7498079" cy="347472"/>
-          </a:xfrm>
-          <a:prstGeom prst="rect">
-            <a:avLst/>
-          </a:prstGeom>
-          <a:noFill/>
-        </p:spPr>
-        <p:txBody>
-          <a:bodyPr wrap="square" anchor="t" lIns="0" rIns="0" tIns="0" bIns="0">
-            <a:spAutoFit/>
-          </a:bodyPr>
-          <a:lstStyle/>
-          <a:p>
-            <a:pPr algn="l">
-              <a:lnSpc>
-                <a:spcPct val="100000"/>
-              </a:lnSpc>
-              <a:spcAft>
-                <a:spcPts val="400"/>
-              </a:spcAft>
-            </a:pPr>
-            <a:r>
-              <a:rPr sz="1450" b="1" i="0">
-                <a:solidFill>
-                  <a:srgbClr val="1F3864"/>
-                </a:solidFill>
-                <a:latin typeface="Segoe UI"/>
-              </a:rPr>
-              <a:t>Q&amp;A</a:t>
-            </a:r>
-          </a:p>
-        </p:txBody>
-      </p:sp>
-      <p:sp>
-        <p:nvSpPr>
-          <p:cNvPr id="30" name="TextBox 29"/>
-          <p:cNvSpPr txBox="1"/>
-          <p:nvPr/>
-        </p:nvSpPr>
-        <p:spPr>
-          <a:xfrm>
-            <a:off x="8778240" y="5440680"/>
-            <a:ext cx="2834640" cy="310896"/>
-          </a:xfrm>
-          <a:prstGeom prst="rect">
-            <a:avLst/>
-          </a:prstGeom>
-          <a:noFill/>
-        </p:spPr>
-        <p:txBody>
-          <a:bodyPr wrap="square" anchor="t" lIns="0" rIns="0" tIns="0" bIns="0">
-            <a:spAutoFit/>
-          </a:bodyPr>
-          <a:lstStyle/>
-          <a:p>
-            <a:pPr algn="r">
-              <a:lnSpc>
-                <a:spcPct val="100000"/>
-              </a:lnSpc>
-              <a:spcAft>
-                <a:spcPts val="400"/>
-              </a:spcAft>
-            </a:pPr>
-            <a:r>
-              <a:rPr sz="1100" b="0" i="0">
-                <a:solidFill>
-                  <a:srgbClr val="8A94A6"/>
-                </a:solidFill>
-                <a:latin typeface="Segoe UI"/>
-              </a:rPr>
-              <a:t>all · 15:00–20:00</a:t>
+              <a:t>all · 10:00–15:00</a:t>
             </a:r>
           </a:p>
         </p:txBody>
@@ -22851,7 +22746,7 @@
                 </a:solidFill>
                 <a:latin typeface="Segoe UI"/>
               </a:rPr>
-              <a:t>FastAPI modular monolith — 16 modules · one deployable</a:t>
+              <a:t>FastAPI modular monolith — 17 modules · one deployable</a:t>
             </a:r>
           </a:p>
         </p:txBody>
@@ -25761,7 +25656,7 @@
                 </a:solidFill>
                 <a:latin typeface="Segoe UI"/>
               </a:rPr>
-              <a:t>EXECUTED → AFFIRMED → SETTLED, automatically.</a:t>
+              <a:t>EXECUTED → AFFIRMED → SETTLED, automatically — every state visible in the settlements list.</a:t>
             </a:r>
           </a:p>
           <a:p>
@@ -25798,7 +25693,7 @@
                 </a:solidFill>
                 <a:latin typeface="Segoe UI"/>
               </a:rPr>
-              <a:t>they surface on the operations dashboard, with audit on every transition.</a:t>
+              <a:t>they surface on the operations dashboard — audited, and ops can retry them there.</a:t>
             </a:r>
           </a:p>
           <a:p>

</xml_diff>